<commit_message>
test(e2e): drop animation-target workaround from transitions fixture
The transitions/animations fixture generator used to post-process the
saved slide 3 XML, rewriting the animation's target id to the exact
positional id the loader would assign, to route around the (now fixed)
animation-to-shape linkage bug. With core writing `p:spTgt/@spid` from
the shape's native `p:cNvPr/@id` and reconciling it back on load, the
SDK-authored deck plays back its entrance animation once reloaded with no
XML surgery. Remove the workaround (and its JSZip post-processing) and
regenerate the fixture.

Co-Authored-By: Claude Sonnet 5 <noreply@anthropic.com>
</commit_message>
<xml_diff>
--- a/viewers/pptx/e2e/fixtures/transitions-animations.pptx
+++ b/viewers/pptx/e2e/fixtures/transitions-animations.pptx
@@ -541,7 +541,7 @@
       </p:sp>
       <p:sp>
         <p:nvSpPr>
-          <p:cNvPr id="4" name="Rectangle 4"/>
+          <p:cNvPr id="2" name="Rectangle 4"/>
           <p:cNvSpPr txBox="0"/>
           <p:nvPr/>
         </p:nvSpPr>
@@ -583,7 +583,7 @@
     <p:ext uri="{A6F62C1B-B45C-4E8A-8B0A-1B3E5F8C8D4A}">
       <pptx:editorMeta>
         <pptx:animations>
-          <pptx:animation elementId="ppt/slides/slide3.xml-shape-1" entrance="fadeIn" durationMs="500" delayMs="0" trigger="onClick"/>
+          <pptx:animation elementId="2" entrance="fadeIn" durationMs="500" delayMs="0" trigger="onClick"/>
         </pptx:animations>
       </pptx:editorMeta>
     </p:ext>
@@ -622,7 +622,7 @@
                                           </p:stCondLst>
                                         </p:cTn>
                                         <p:tgtEl>
-                                          <p:spTgt spid="ppt/slides/slide3.xml-shape-1"/>
+                                          <p:spTgt spid="2"/>
                                         </p:tgtEl>
                                         <p:attrNameLst>
                                           <p:attrName>style.visibility</p:attrName>
@@ -636,7 +636,7 @@
                                       <p:cBhvr>
                                         <p:cTn id="3" dur="500"/>
                                         <p:tgtEl>
-                                          <p:spTgt spid="ppt/slides/slide3.xml-shape-1"/>
+                                          <p:spTgt spid="2"/>
                                         </p:tgtEl>
                                       </p:cBhvr>
                                     </p:animEffect>

</xml_diff>